<commit_message>
docs: attach Slide 11 (References & Benchmark Literature) across Canva markdown, PPTX, PDF, HTML, and Beamer LaTeX
</commit_message>
<xml_diff>
--- a/docs/Progress_Report/Presentation.pptx
+++ b/docs/Progress_Report/Presentation.pptx
@@ -15,6 +15,7 @@
     <p:sldId id="263" r:id="rId15"/>
     <p:sldId id="264" r:id="rId16"/>
     <p:sldId id="265" r:id="rId17"/>
+    <p:sldId id="266" r:id="rId18"/>
   </p:sldIdLst>
   <p:sldSz cx="12191695" cy="6858000" type="screen4x3"/>
   <p:notesSz cx="6858000" cy="9144000"/>
@@ -582,6 +583,76 @@
           <a:p>
             <a:r>
               <a:t>To conclude: this project bridges machine learning, discrete-event digital twins, and disciplined corporate entrepreneurship. We did not cherry-pick our data or claim artificial perfection—we demonstrated exactly where classical ML provides real operational runway, where deep learning lags, and how an organization can rigorously evaluate technology under uncertainty. Thank you, and I look forward to your questions.</a:t>
+            </a:r>
+          </a:p>
+        </p:txBody>
+      </p:sp>
+      <p:sp>
+        <p:nvSpPr>
+          <p:cNvPr id="4" name="Slide Number Placeholder 3"/>
+          <p:cNvSpPr>
+            <a:spLocks noGrp="1"/>
+          </p:cNvSpPr>
+          <p:nvPr>
+            <p:ph type="sldNum" idx="5" sz="quarter"/>
+          </p:nvPr>
+        </p:nvSpPr>
+        <p:spPr/>
+      </p:sp>
+    </p:spTree>
+  </p:cSld>
+  <p:clrMapOvr>
+    <a:masterClrMapping/>
+  </p:clrMapOvr>
+</p:notes>
+</file>
+
+<file path=ppt/notesSlides/notesSlide11.xml><?xml version="1.0" encoding="utf-8"?>
+<p:notes xmlns:a="http://schemas.openxmlformats.org/drawingml/2006/main" xmlns:p="http://schemas.openxmlformats.org/presentationml/2006/main" xmlns:r="http://schemas.openxmlformats.org/officeDocument/2006/relationships">
+  <p:cSld>
+    <p:spTree>
+      <p:nvGrpSpPr>
+        <p:cNvPr id="1" name=""/>
+        <p:cNvGrpSpPr/>
+        <p:nvPr/>
+      </p:nvGrpSpPr>
+      <p:grpSpPr>
+        <a:xfrm>
+          <a:off x="0" y="0"/>
+          <a:ext cx="0" cy="0"/>
+          <a:chOff x="0" y="0"/>
+          <a:chExt cx="0" cy="0"/>
+        </a:xfrm>
+      </p:grpSpPr>
+      <p:sp>
+        <p:nvSpPr>
+          <p:cNvPr id="2" name="Slide Image Placeholder 1"/>
+          <p:cNvSpPr>
+            <a:spLocks noGrp="1"/>
+          </p:cNvSpPr>
+          <p:nvPr>
+            <p:ph type="sldImg" idx="2"/>
+          </p:nvPr>
+        </p:nvSpPr>
+        <p:spPr/>
+      </p:sp>
+      <p:sp>
+        <p:nvSpPr>
+          <p:cNvPr id="3" name="Notes Placeholder 2"/>
+          <p:cNvSpPr>
+            <a:spLocks noGrp="1"/>
+          </p:cNvSpPr>
+          <p:nvPr>
+            <p:ph type="body" idx="3" sz="quarter"/>
+          </p:nvPr>
+        </p:nvSpPr>
+        <p:spPr/>
+        <p:txBody>
+          <a:bodyPr/>
+          <a:lstStyle/>
+          <a:p>
+            <a:r>
+              <a:t>Finally, our research is thoroughly grounded in contemporary peer-reviewed literature across food engineering, industrial digital twins, and machine learning. Here are the core benchmark references supporting our methodology and empirical findings. Thank you, and I am now happy to take any questions.</a:t>
             </a:r>
           </a:p>
         </p:txBody>
@@ -4702,6 +4773,437 @@
             </a:pPr>
             <a:r>
               <a:t>Thank you for your time! | Open for Questions &amp; Interactive Dashboard Demonstration</a:t>
+            </a:r>
+          </a:p>
+        </p:txBody>
+      </p:sp>
+    </p:spTree>
+  </p:cSld>
+  <p:clrMapOvr>
+    <a:masterClrMapping/>
+  </p:clrMapOvr>
+</p:sld>
+</file>
+
+<file path=ppt/slides/slide11.xml><?xml version="1.0" encoding="utf-8"?>
+<p:sld xmlns:a="http://schemas.openxmlformats.org/drawingml/2006/main" xmlns:p="http://schemas.openxmlformats.org/presentationml/2006/main" xmlns:r="http://schemas.openxmlformats.org/officeDocument/2006/relationships">
+  <p:cSld>
+    <p:spTree>
+      <p:nvGrpSpPr>
+        <p:cNvPr id="1" name=""/>
+        <p:cNvGrpSpPr/>
+        <p:nvPr/>
+      </p:nvGrpSpPr>
+      <p:grpSpPr/>
+      <p:sp>
+        <p:nvSpPr>
+          <p:cNvPr id="2" name="Rectangle 1"/>
+          <p:cNvSpPr/>
+          <p:nvPr/>
+        </p:nvSpPr>
+        <p:spPr>
+          <a:xfrm>
+            <a:off x="0" y="0"/>
+            <a:ext cx="12191695" cy="1005840"/>
+          </a:xfrm>
+          <a:prstGeom prst="rect">
+            <a:avLst/>
+          </a:prstGeom>
+          <a:solidFill>
+            <a:srgbClr val="0E264D"/>
+          </a:solidFill>
+          <a:ln w="31750">
+            <a:solidFill>
+              <a:srgbClr val="0284C7"/>
+            </a:solidFill>
+          </a:ln>
+        </p:spPr>
+        <p:style>
+          <a:lnRef idx="1">
+            <a:schemeClr val="accent1"/>
+          </a:lnRef>
+          <a:fillRef idx="3">
+            <a:schemeClr val="accent1"/>
+          </a:fillRef>
+          <a:effectRef idx="2">
+            <a:schemeClr val="accent1"/>
+          </a:effectRef>
+          <a:fontRef idx="minor">
+            <a:schemeClr val="lt1"/>
+          </a:fontRef>
+        </p:style>
+        <p:txBody>
+          <a:bodyPr rtlCol="0" anchor="ctr" wrap="square"/>
+          <a:lstStyle/>
+          <a:p>
+            <a:pPr algn="l">
+              <a:spcAft>
+                <a:spcPts val="200"/>
+              </a:spcAft>
+              <a:defRPr sz="2200" b="1">
+                <a:solidFill>
+                  <a:srgbClr val="FFFFFF"/>
+                </a:solidFill>
+                <a:latin typeface="Calibri"/>
+              </a:defRPr>
+            </a:pPr>
+            <a:r>
+              <a:t>References &amp; Benchmark Literature</a:t>
+            </a:r>
+          </a:p>
+          <a:p>
+            <a:pPr algn="l">
+              <a:defRPr sz="1100">
+                <a:solidFill>
+                  <a:srgbClr val="BAE6FD"/>
+                </a:solidFill>
+                <a:latin typeface="Calibri"/>
+              </a:defRPr>
+            </a:pPr>
+            <a:r>
+              <a:t>Topic 21 — Digital Twin Early Warning System</a:t>
+            </a:r>
+          </a:p>
+        </p:txBody>
+      </p:sp>
+      <p:pic>
+        <p:nvPicPr>
+          <p:cNvPr id="3" name="Picture 2" descr="iiit_allahabad_logo.png"/>
+          <p:cNvPicPr>
+            <a:picLocks noChangeAspect="1"/>
+          </p:cNvPicPr>
+          <p:nvPr/>
+        </p:nvPicPr>
+        <p:blipFill>
+          <a:blip r:embed="rId2"/>
+          <a:stretch>
+            <a:fillRect/>
+          </a:stretch>
+        </p:blipFill>
+        <p:spPr>
+          <a:xfrm>
+            <a:off x="11292840" y="109728"/>
+            <a:ext cx="735869" cy="777240"/>
+          </a:xfrm>
+          <a:prstGeom prst="rect">
+            <a:avLst/>
+          </a:prstGeom>
+        </p:spPr>
+      </p:pic>
+      <p:sp>
+        <p:nvSpPr>
+          <p:cNvPr id="4" name="TextBox 3"/>
+          <p:cNvSpPr txBox="1"/>
+          <p:nvPr/>
+        </p:nvSpPr>
+        <p:spPr>
+          <a:xfrm>
+            <a:off x="731520" y="6537960"/>
+            <a:ext cx="10728655" cy="274320"/>
+          </a:xfrm>
+          <a:prstGeom prst="rect">
+            <a:avLst/>
+          </a:prstGeom>
+          <a:noFill/>
+        </p:spPr>
+        <p:txBody>
+          <a:bodyPr wrap="none" anchor="ctr">
+            <a:spAutoFit/>
+          </a:bodyPr>
+          <a:lstStyle/>
+          <a:p>
+            <a:pPr algn="l">
+              <a:defRPr sz="950">
+                <a:solidFill>
+                  <a:srgbClr val="94A3B8"/>
+                </a:solidFill>
+                <a:latin typeface="Calibri"/>
+              </a:defRPr>
+            </a:pPr>
+            <a:r>
+              <a:t>Managing Corporate Entrepreneurship (B.Tech 7th Sem) | Krishna Sikheriya (IIT2023139) | IIIT Allahabad</a:t>
+            </a:r>
+          </a:p>
+        </p:txBody>
+      </p:sp>
+      <p:sp>
+        <p:nvSpPr>
+          <p:cNvPr id="5" name="Rounded Rectangle 4"/>
+          <p:cNvSpPr/>
+          <p:nvPr/>
+        </p:nvSpPr>
+        <p:spPr>
+          <a:xfrm>
+            <a:off x="731520" y="1280160"/>
+            <a:ext cx="5120640" cy="4937760"/>
+          </a:xfrm>
+          <a:prstGeom prst="roundRect">
+            <a:avLst/>
+          </a:prstGeom>
+          <a:solidFill>
+            <a:srgbClr val="F0F7FF"/>
+          </a:solidFill>
+          <a:ln>
+            <a:solidFill>
+              <a:srgbClr val="CBD5E1"/>
+            </a:solidFill>
+          </a:ln>
+        </p:spPr>
+        <p:style>
+          <a:lnRef idx="1">
+            <a:schemeClr val="accent1"/>
+          </a:lnRef>
+          <a:fillRef idx="3">
+            <a:schemeClr val="accent1"/>
+          </a:fillRef>
+          <a:effectRef idx="2">
+            <a:schemeClr val="accent1"/>
+          </a:effectRef>
+          <a:fontRef idx="minor">
+            <a:schemeClr val="lt1"/>
+          </a:fontRef>
+        </p:style>
+        <p:txBody>
+          <a:bodyPr rtlCol="0" anchor="ctr" wrap="square"/>
+          <a:lstStyle/>
+          <a:p>
+            <a:pPr algn="ctr">
+              <a:spcAft>
+                <a:spcPts val="800"/>
+              </a:spcAft>
+              <a:defRPr sz="1500" b="1">
+                <a:solidFill>
+                  <a:srgbClr val="0E264D"/>
+                </a:solidFill>
+                <a:latin typeface="Calibri"/>
+              </a:defRPr>
+            </a:pPr>
+            <a:r>
+              <a:t>Recent Cold-Chain Benchmarks (2023–2026)</a:t>
+            </a:r>
+          </a:p>
+          <a:p>
+            <a:pPr>
+              <a:spcAft>
+                <a:spcPts val="600"/>
+              </a:spcAft>
+              <a:defRPr sz="950">
+                <a:solidFill>
+                  <a:srgbClr val="1E293B"/>
+                </a:solidFill>
+              </a:defRPr>
+            </a:pPr>
+            <a:r>
+              <a:t>1. Vukšić, M., Ćelić, J., Ogrizović, D., &amp; Perić Hadžić, A. (2026). Early Anomaly Detection in Maritime Refrigerated Containers Using a Hybrid Digital Twin and Deep Learning Framework. Applied Sciences, 16(4), 1887.</a:t>
+            </a:r>
+          </a:p>
+          <a:p>
+            <a:pPr>
+              <a:spcAft>
+                <a:spcPts val="600"/>
+              </a:spcAft>
+              <a:defRPr sz="950">
+                <a:solidFill>
+                  <a:srgbClr val="1E293B"/>
+                </a:solidFill>
+              </a:defRPr>
+            </a:pPr>
+            <a:r>
+              <a:t>2. Xie, Z., Long, H., Ling, C., Zhou, Y., &amp; Luo, Y. (2025). An Anomaly Detection Scheme for Data Stream in Cold Chain Logistics. PLOS ONE, 20(3), e0315322.</a:t>
+            </a:r>
+          </a:p>
+          <a:p>
+            <a:pPr>
+              <a:spcAft>
+                <a:spcPts val="600"/>
+              </a:spcAft>
+              <a:defRPr sz="950">
+                <a:solidFill>
+                  <a:srgbClr val="1E293B"/>
+                </a:solidFill>
+              </a:defRPr>
+            </a:pPr>
+            <a:r>
+              <a:t>3. Meng, X., Xie, R., Liao, J., Shen, X., &amp; Yang, S. (2024). A Cost-Effective Over-Temperature Alarm System for Cold Chain Delivery. Journal of Food Engineering, 368, 111914.</a:t>
+            </a:r>
+          </a:p>
+          <a:p>
+            <a:pPr>
+              <a:spcAft>
+                <a:spcPts val="600"/>
+              </a:spcAft>
+              <a:defRPr sz="950">
+                <a:solidFill>
+                  <a:srgbClr val="1E293B"/>
+                </a:solidFill>
+              </a:defRPr>
+            </a:pPr>
+            <a:r>
+              <a:t>4. Wu, W., Shen, L., Zhao, Z., Harish, A. R., Zhong, R. Y., &amp; Huang, G. Q. (2023). Internet of Everything and Digital Twin Enabled Service Platform for Cold Chain Logistics. Journal of Industrial Information Integration, 33, 100443.</a:t>
+            </a:r>
+          </a:p>
+          <a:p>
+            <a:pPr>
+              <a:spcAft>
+                <a:spcPts val="600"/>
+              </a:spcAft>
+              <a:defRPr sz="950">
+                <a:solidFill>
+                  <a:srgbClr val="1E293B"/>
+                </a:solidFill>
+              </a:defRPr>
+            </a:pPr>
+            <a:r>
+              <a:t>5. Defraeye, T., Shrivastava, C., Berry, T., Verboven, P., Onwude, D., Schudel, S., et al. (2023). Digital Twins of Food Cold Chains: Advances, Challenges, and Opportunities. Computers and Electronics in Agriculture, 214, 108252.</a:t>
+            </a:r>
+          </a:p>
+        </p:txBody>
+      </p:sp>
+      <p:sp>
+        <p:nvSpPr>
+          <p:cNvPr id="6" name="Rounded Rectangle 5"/>
+          <p:cNvSpPr/>
+          <p:nvPr/>
+        </p:nvSpPr>
+        <p:spPr>
+          <a:xfrm>
+            <a:off x="6217920" y="1280160"/>
+            <a:ext cx="5212080" cy="4937760"/>
+          </a:xfrm>
+          <a:prstGeom prst="roundRect">
+            <a:avLst/>
+          </a:prstGeom>
+          <a:solidFill>
+            <a:srgbClr val="FFFFFF"/>
+          </a:solidFill>
+          <a:ln w="19050">
+            <a:solidFill>
+              <a:srgbClr val="0284C7"/>
+            </a:solidFill>
+          </a:ln>
+        </p:spPr>
+        <p:style>
+          <a:lnRef idx="1">
+            <a:schemeClr val="accent1"/>
+          </a:lnRef>
+          <a:fillRef idx="3">
+            <a:schemeClr val="accent1"/>
+          </a:fillRef>
+          <a:effectRef idx="2">
+            <a:schemeClr val="accent1"/>
+          </a:effectRef>
+          <a:fontRef idx="minor">
+            <a:schemeClr val="lt1"/>
+          </a:fontRef>
+        </p:style>
+        <p:txBody>
+          <a:bodyPr rtlCol="0" anchor="ctr" wrap="square"/>
+          <a:lstStyle/>
+          <a:p>
+            <a:pPr algn="ctr">
+              <a:spcAft>
+                <a:spcPts val="800"/>
+              </a:spcAft>
+              <a:defRPr sz="1500" b="1">
+                <a:solidFill>
+                  <a:srgbClr val="0284C7"/>
+                </a:solidFill>
+                <a:latin typeface="Calibri"/>
+              </a:defRPr>
+            </a:pPr>
+            <a:r>
+              <a:t>Foundational Algorithms &amp; Project Assets</a:t>
+            </a:r>
+          </a:p>
+          <a:p>
+            <a:pPr>
+              <a:spcAft>
+                <a:spcPts val="600"/>
+              </a:spcAft>
+              <a:defRPr sz="1000">
+                <a:solidFill>
+                  <a:srgbClr val="1E293B"/>
+                </a:solidFill>
+              </a:defRPr>
+            </a:pPr>
+            <a:r>
+              <a:t>6. Liu, F. T., Ting, K. M., &amp; Zhou, Z.-H. (2008). Isolation Forest. 2008 Eighth IEEE International Conference on Data Mining (ICDM), 413–422.</a:t>
+            </a:r>
+          </a:p>
+          <a:p>
+            <a:pPr>
+              <a:spcAft>
+                <a:spcPts val="600"/>
+              </a:spcAft>
+              <a:defRPr sz="1000">
+                <a:solidFill>
+                  <a:srgbClr val="1E293B"/>
+                </a:solidFill>
+              </a:defRPr>
+            </a:pPr>
+            <a:r>
+              <a:t>7. Malhotra, P., Ramakrishnan, A., Anand, G., Vig, L., Agarwal, P., &amp; Shroff, G. (2016). LSTM-based Encoder-Decoder for Multi-sensor Anomaly Detection. ICML 2016 Anomaly Detection Workshop.</a:t>
+            </a:r>
+          </a:p>
+          <a:p>
+            <a:pPr>
+              <a:spcAft>
+                <a:spcPts val="600"/>
+              </a:spcAft>
+              <a:defRPr sz="1000">
+                <a:solidFill>
+                  <a:srgbClr val="1E293B"/>
+                </a:solidFill>
+              </a:defRPr>
+            </a:pPr>
+            <a:r>
+              <a:t>8. Anand Jha, A. (2018). Temperature Readings: IoT Devices Telemetry Dataset. Kaggle Datasets (Structural Proxy Dataset).</a:t>
+            </a:r>
+          </a:p>
+          <a:p>
+            <a:br/>
+            <a:pPr>
+              <a:spcAft>
+                <a:spcPts val="600"/>
+              </a:spcAft>
+              <a:defRPr sz="1000">
+                <a:solidFill>
+                  <a:srgbClr val="1E293B"/>
+                </a:solidFill>
+              </a:defRPr>
+            </a:pPr>
+            <a:r>
+              <a:t>• Live Deployed Dashboard: https://coldchain-ews-twin.streamlit.app/</a:t>
+            </a:r>
+          </a:p>
+          <a:p>
+            <a:pPr>
+              <a:spcAft>
+                <a:spcPts val="600"/>
+              </a:spcAft>
+              <a:defRPr sz="1000">
+                <a:solidFill>
+                  <a:srgbClr val="1E293B"/>
+                </a:solidFill>
+              </a:defRPr>
+            </a:pPr>
+            <a:r>
+              <a:t>• Open-Source Code Repository: https://github.com/Krishna200608/coldchain-ews-twin</a:t>
+            </a:r>
+          </a:p>
+          <a:p>
+            <a:pPr>
+              <a:spcAft>
+                <a:spcPts val="600"/>
+              </a:spcAft>
+              <a:defRPr sz="1000">
+                <a:solidFill>
+                  <a:srgbClr val="1E293B"/>
+                </a:solidFill>
+              </a:defRPr>
+            </a:pPr>
+            <a:r>
+              <a:t>• Institution: Department of Information Technology, IIIT Allahabad</a:t>
             </a:r>
           </a:p>
         </p:txBody>

</xml_diff>